<commit_message>
New version of the presentation
</commit_message>
<xml_diff>
--- a/deliverables/Nanoplastics_scRNAseq_Presentation (3).pptx
+++ b/deliverables/Nanoplastics_scRNAseq_Presentation (3).pptx
@@ -127,7 +127,7 @@
 </p:presentation>
 </file>
 
-<file path=ppt/charts/chart2.xml><?xml version="1.0" encoding="utf-8"?>
+<file path=ppt/charts/chart1.xml><?xml version="1.0" encoding="utf-8"?>
 <c:chartSpace xmlns:c="http://schemas.openxmlformats.org/drawingml/2006/chart" xmlns:a="http://schemas.openxmlformats.org/drawingml/2006/main" xmlns:r="http://schemas.openxmlformats.org/officeDocument/2006/relationships" xmlns:c16r2="http://schemas.microsoft.com/office/drawing/2015/06/chart">
   <c:date1904 val="0"/>
   <c:lang val="en-US"/>
@@ -628,7 +628,15 @@
           <a:p>
             <a:r>
               <a:rPr lang="en-US" dirty="0"/>
-              <a:t>Welcome everyone. This presentation covers our single-cell RNA sequencing study of how nanoplastic particles of different sizes affect human immune cells in blood. We have four conditions from one donor: 40 nm nanoparticles, 200 nm nanoparticles, a mixture of both sizes, and an untreated control. In total we analysed over 33,000 immune cells. The key biological question is: does particle size reshape the immune transcriptional response at single-cell resolution?</a:t>
+              <a:t>Hello everyone, today my colleague Ana and I are going to present our single-cell RNA-seq investigation into how </a:t>
+            </a:r>
+            <a:r>
+              <a:rPr lang="en-US" dirty="0" err="1"/>
+              <a:t>nanoplastic</a:t>
+            </a:r>
+            <a:r>
+              <a:rPr lang="en-US" dirty="0"/>
+              <a:t> particle size affects human immune cells. Our hypothesis: nanoparticle size alters both immune cell composition and gene expression in human PBMCs. Let’s get into it.</a:t>
             </a:r>
           </a:p>
         </p:txBody>
@@ -1324,7 +1332,15 @@
           <a:p>
             <a:r>
               <a:rPr lang="en-US" dirty="0"/>
-              <a:t>Plastic pollution is a global environmental crisis. Large plastics fragment into nanoplastics smaller than one micrometre that persist in ecosystems and have now been detected in human blood. When these particles enter the bloodstream they interact directly with peripheral blood immune cells. A key question is whether particle size matters — smaller 40 nm particles have a much higher surface-to-volume ratio and may cross membranes more easily than 200 nm particles, potentially triggering different immune programmes. Our central hypothesis is that particle size reshapes immune cell composition and gene expression.</a:t>
+              <a:t>Briefly — plastic debris breaks down into </a:t>
+            </a:r>
+            <a:r>
+              <a:rPr lang="en-US" dirty="0" err="1"/>
+              <a:t>nanoplastics</a:t>
+            </a:r>
+            <a:r>
+              <a:rPr lang="en-US" dirty="0"/>
+              <a:t> under a micron in size, and these are now being found in oceans, food, air, and even human blood. Because they’re so small, they come into direct contact with circulating immune cells — T cells, B cells, NK cells, and monocytes. And critically, size itself matters: smaller particles cross biological barriers more easily and take different routes into the cell, which could mean very different immune consequences depending on particle size.</a:t>
             </a:r>
           </a:p>
         </p:txBody>
@@ -2870,7 +2886,7 @@
                 <a:ea typeface="Calibri" pitchFamily="34" charset="-122"/>
                 <a:cs typeface="Calibri" pitchFamily="34" charset="-120"/>
               </a:rPr>
-              <a:t xml:space="preserve">Ana </a:t>
+              <a:t>Ana </a:t>
             </a:r>
             <a:r>
               <a:rPr lang="en-US" sz="1400" i="1" dirty="0" err="1">
@@ -2903,7 +2919,7 @@
                 <a:ea typeface="Calibri" pitchFamily="34" charset="-122"/>
                 <a:cs typeface="Calibri" pitchFamily="34" charset="-120"/>
               </a:rPr>
-              <a:t xml:space="preserve">/3046 </a:t>
+              <a:t>/3046 </a:t>
             </a:r>
           </a:p>
           <a:p>
@@ -2919,7 +2935,7 @@
                 <a:ea typeface="Calibri" pitchFamily="34" charset="-122"/>
                 <a:cs typeface="Calibri" pitchFamily="34" charset="-120"/>
               </a:rPr>
-              <a:t xml:space="preserve">Marija </a:t>
+              <a:t>Marija </a:t>
             </a:r>
             <a:r>
               <a:rPr lang="en-US" sz="1400" i="1" dirty="0" err="1">
@@ -5034,7 +5050,7 @@
         </p:nvSpPr>
         <p:spPr>
           <a:xfrm>
-            <a:off x="457200" y="4370832"/>
+            <a:off x="457200" y="4690872"/>
             <a:ext cx="8229600" cy="429768"/>
           </a:xfrm>
           <a:prstGeom prst="roundRect">
@@ -5064,17 +5080,30 @@
         <p:spPr>
           <a:xfrm>
             <a:off x="594360" y="4370832"/>
-            <a:ext cx="7955280" cy="429768"/>
-          </a:xfrm>
-          <a:prstGeom prst="rect">
-            <a:avLst/>
-          </a:prstGeom>
-          <a:noFill/>
-          <a:ln/>
-        </p:spPr>
-        <p:txBody>
-          <a:bodyPr wrap="square" rtlCol="0" anchor="ctr"/>
-          <a:lstStyle/>
+            <a:ext cx="7955280" cy="906562"/>
+          </a:xfrm>
+          <a:prstGeom prst="rect">
+            <a:avLst/>
+          </a:prstGeom>
+          <a:noFill/>
+          <a:ln/>
+        </p:spPr>
+        <p:txBody>
+          <a:bodyPr wrap="square" rtlCol="0" anchor="ctr"/>
+          <a:lstStyle/>
+          <a:p>
+            <a:pPr marL="0" indent="0">
+              <a:buNone/>
+            </a:pPr>
+            <a:endParaRPr lang="en-US" sz="1200" b="1" dirty="0">
+              <a:solidFill>
+                <a:srgbClr val="FFFFFF"/>
+              </a:solidFill>
+              <a:latin typeface="Calibri" pitchFamily="34" charset="0"/>
+              <a:ea typeface="Calibri" pitchFamily="34" charset="-122"/>
+              <a:cs typeface="Calibri" pitchFamily="34" charset="-120"/>
+            </a:endParaRPr>
+          </a:p>
           <a:p>
             <a:pPr marL="0" indent="0">
               <a:buNone/>
@@ -15304,7 +15333,7 @@
           <p:nvPr/>
         </p:nvPicPr>
         <p:blipFill>
-          <a:blip r:embed="rId10"/>
+          <a:blip r:embed="rId3"/>
           <a:stretch>
             <a:fillRect/>
           </a:stretch>
@@ -15328,7 +15357,7 @@
           <p:nvPr/>
         </p:nvPicPr>
         <p:blipFill>
-          <a:blip r:embed="rId11"/>
+          <a:blip r:embed="rId4"/>
           <a:stretch>
             <a:fillRect/>
           </a:stretch>
@@ -15352,7 +15381,7 @@
           <p:nvPr/>
         </p:nvPicPr>
         <p:blipFill>
-          <a:blip r:embed="rId12"/>
+          <a:blip r:embed="rId5"/>
           <a:stretch>
             <a:fillRect/>
           </a:stretch>
@@ -17560,7 +17589,7 @@
                 <a:ea typeface="Calibri" pitchFamily="34" charset="-122"/>
                 <a:cs typeface="Calibri" pitchFamily="34" charset="-120"/>
               </a:rPr>
-              <a:t xml:space="preserve">Largest populations: </a:t>
+              <a:t>Largest populations: </a:t>
             </a:r>
             <a:endParaRPr lang="en-US" sz="1200" dirty="0"/>
           </a:p>
@@ -17599,7 +17628,7 @@
                 <a:ea typeface="Calibri" pitchFamily="34" charset="-122"/>
                 <a:cs typeface="Calibri" pitchFamily="34" charset="-120"/>
               </a:rPr>
-              <a:t xml:space="preserve">  CD4+ T: 15,568  ·  NK: 5,812  ·  B cells: 4,820  ·  CD8+ T: 3,902  ·  CD14+ Mono: 2,230  </a:t>
+              <a:t>  CD4+ T: 15,568  ·  NK: 5,812  ·  B cells: 4,820  ·  CD8+ T: 3,902  ·  CD14+ Mono: 2,230  </a:t>
             </a:r>
             <a:endParaRPr lang="en-US" sz="1200" dirty="0"/>
           </a:p>
@@ -17686,7 +17715,7 @@
           <p:nvPr/>
         </p:nvPicPr>
         <p:blipFill>
-          <a:blip r:embed="rId10"/>
+          <a:blip r:embed="rId3"/>
           <a:stretch>
             <a:fillRect/>
           </a:stretch>
@@ -17957,7 +17986,7 @@
                 <a:ea typeface="Calibri" pitchFamily="34" charset="-122"/>
                 <a:cs typeface="Calibri" pitchFamily="34" charset="-120"/>
               </a:rPr>
-              <a:t xml:space="preserve"> — dominant population</a:t>
+              <a:t> — dominant population</a:t>
             </a:r>
             <a:endParaRPr lang="en-US" sz="1100" dirty="0"/>
           </a:p>
@@ -18683,10 +18712,34 @@
             <a:tbl>
               <a:tblPr firstRow="1" bandRow="1"/>
               <a:tblGrid>
-                <a:gridCol w="1152144"/>
-                <a:gridCol w="1152144"/>
-                <a:gridCol w="1316736"/>
-                <a:gridCol w="4608576"/>
+                <a:gridCol w="1152144">
+                  <a:extLst>
+                    <a:ext uri="{9D8B030D-6E8A-4147-A177-3AD203B41FA5}">
+                      <a16:colId xmlns:a16="http://schemas.microsoft.com/office/drawing/2014/main" val="20000"/>
+                    </a:ext>
+                  </a:extLst>
+                </a:gridCol>
+                <a:gridCol w="1152144">
+                  <a:extLst>
+                    <a:ext uri="{9D8B030D-6E8A-4147-A177-3AD203B41FA5}">
+                      <a16:colId xmlns:a16="http://schemas.microsoft.com/office/drawing/2014/main" val="20001"/>
+                    </a:ext>
+                  </a:extLst>
+                </a:gridCol>
+                <a:gridCol w="1316736">
+                  <a:extLst>
+                    <a:ext uri="{9D8B030D-6E8A-4147-A177-3AD203B41FA5}">
+                      <a16:colId xmlns:a16="http://schemas.microsoft.com/office/drawing/2014/main" val="20002"/>
+                    </a:ext>
+                  </a:extLst>
+                </a:gridCol>
+                <a:gridCol w="4608576">
+                  <a:extLst>
+                    <a:ext uri="{9D8B030D-6E8A-4147-A177-3AD203B41FA5}">
+                      <a16:colId xmlns:a16="http://schemas.microsoft.com/office/drawing/2014/main" val="20003"/>
+                    </a:ext>
+                  </a:extLst>
+                </a:gridCol>
               </a:tblGrid>
               <a:tr h="320000">
                 <a:tc>
@@ -18710,7 +18763,7 @@
                       </a:r>
                     </a:p>
                   </a:txBody>
-                  <a:tcPr marL="91440" marR="91440" marT="36576" marB="36576" anchor="ctr">
+                  <a:tcPr marT="36576" marB="36576" anchor="ctr">
                     <a:lnL w="6350" cap="flat" cmpd="sng" algn="ctr">
                       <a:solidFill>
                         <a:srgbClr val="CCDFE8"/>
@@ -18761,7 +18814,7 @@
                       </a:r>
                     </a:p>
                   </a:txBody>
-                  <a:tcPr marL="91440" marR="91440" marT="36576" marB="36576" anchor="ctr">
+                  <a:tcPr marT="36576" marB="36576" anchor="ctr">
                     <a:lnL w="6350" cap="flat" cmpd="sng" algn="ctr">
                       <a:solidFill>
                         <a:srgbClr val="CCDFE8"/>
@@ -18812,7 +18865,7 @@
                       </a:r>
                     </a:p>
                   </a:txBody>
-                  <a:tcPr marL="91440" marR="91440" marT="36576" marB="36576" anchor="ctr">
+                  <a:tcPr marT="36576" marB="36576" anchor="ctr">
                     <a:lnL w="6350" cap="flat" cmpd="sng" algn="ctr">
                       <a:solidFill>
                         <a:srgbClr val="CCDFE8"/>
@@ -18863,7 +18916,7 @@
                       </a:r>
                     </a:p>
                   </a:txBody>
-                  <a:tcPr marL="91440" marR="91440" marT="36576" marB="36576" anchor="ctr">
+                  <a:tcPr marT="36576" marB="36576" anchor="ctr">
                     <a:lnL w="6350" cap="flat" cmpd="sng" algn="ctr">
                       <a:solidFill>
                         <a:srgbClr val="CCDFE8"/>
@@ -18893,6 +18946,11 @@
                     </a:solidFill>
                   </a:tcPr>
                 </a:tc>
+                <a:extLst>
+                  <a:ext uri="{0D108BD9-81ED-4DB2-BD59-A6C34878D82A}">
+                    <a16:rowId xmlns:a16="http://schemas.microsoft.com/office/drawing/2014/main" val="10000"/>
+                  </a:ext>
+                </a:extLst>
               </a:tr>
               <a:tr h="280000">
                 <a:tc>
@@ -18916,7 +18974,7 @@
                       </a:r>
                     </a:p>
                   </a:txBody>
-                  <a:tcPr marL="91440" marR="91440" marT="36576" marB="36576" anchor="ctr">
+                  <a:tcPr marT="36576" marB="36576" anchor="ctr">
                     <a:lnL w="6350" cap="flat" cmpd="sng" algn="ctr">
                       <a:solidFill>
                         <a:srgbClr val="CCDFE8"/>
@@ -18967,7 +19025,7 @@
                       </a:r>
                     </a:p>
                   </a:txBody>
-                  <a:tcPr marL="91440" marR="91440" marT="36576" marB="36576" anchor="ctr">
+                  <a:tcPr marT="36576" marB="36576" anchor="ctr">
                     <a:lnL w="6350" cap="flat" cmpd="sng" algn="ctr">
                       <a:solidFill>
                         <a:srgbClr val="CCDFE8"/>
@@ -19018,7 +19076,7 @@
                       </a:r>
                     </a:p>
                   </a:txBody>
-                  <a:tcPr marL="91440" marR="91440" marT="36576" marB="36576" anchor="ctr">
+                  <a:tcPr marT="36576" marB="36576" anchor="ctr">
                     <a:lnL w="6350" cap="flat" cmpd="sng" algn="ctr">
                       <a:solidFill>
                         <a:srgbClr val="CCDFE8"/>
@@ -19069,7 +19127,7 @@
                       </a:r>
                     </a:p>
                   </a:txBody>
-                  <a:tcPr marL="91440" marR="91440" marT="36576" marB="36576" anchor="ctr">
+                  <a:tcPr marT="36576" marB="36576" anchor="ctr">
                     <a:lnL w="6350" cap="flat" cmpd="sng" algn="ctr">
                       <a:solidFill>
                         <a:srgbClr val="CCDFE8"/>
@@ -19099,6 +19157,11 @@
                     </a:solidFill>
                   </a:tcPr>
                 </a:tc>
+                <a:extLst>
+                  <a:ext uri="{0D108BD9-81ED-4DB2-BD59-A6C34878D82A}">
+                    <a16:rowId xmlns:a16="http://schemas.microsoft.com/office/drawing/2014/main" val="10001"/>
+                  </a:ext>
+                </a:extLst>
               </a:tr>
               <a:tr h="280000">
                 <a:tc>
@@ -19122,7 +19185,7 @@
                       </a:r>
                     </a:p>
                   </a:txBody>
-                  <a:tcPr marL="91440" marR="91440" marT="36576" marB="36576" anchor="ctr">
+                  <a:tcPr marT="36576" marB="36576" anchor="ctr">
                     <a:lnL w="6350" cap="flat" cmpd="sng" algn="ctr">
                       <a:solidFill>
                         <a:srgbClr val="CCDFE8"/>
@@ -19173,7 +19236,7 @@
                       </a:r>
                     </a:p>
                   </a:txBody>
-                  <a:tcPr marL="91440" marR="91440" marT="36576" marB="36576" anchor="ctr">
+                  <a:tcPr marT="36576" marB="36576" anchor="ctr">
                     <a:lnL w="6350" cap="flat" cmpd="sng" algn="ctr">
                       <a:solidFill>
                         <a:srgbClr val="CCDFE8"/>
@@ -19224,7 +19287,7 @@
                       </a:r>
                     </a:p>
                   </a:txBody>
-                  <a:tcPr marL="91440" marR="91440" marT="36576" marB="36576" anchor="ctr">
+                  <a:tcPr marT="36576" marB="36576" anchor="ctr">
                     <a:lnL w="6350" cap="flat" cmpd="sng" algn="ctr">
                       <a:solidFill>
                         <a:srgbClr val="CCDFE8"/>
@@ -19275,7 +19338,7 @@
                       </a:r>
                     </a:p>
                   </a:txBody>
-                  <a:tcPr marL="91440" marR="91440" marT="36576" marB="36576" anchor="ctr">
+                  <a:tcPr marT="36576" marB="36576" anchor="ctr">
                     <a:lnL w="6350" cap="flat" cmpd="sng" algn="ctr">
                       <a:solidFill>
                         <a:srgbClr val="CCDFE8"/>
@@ -19305,6 +19368,11 @@
                     </a:solidFill>
                   </a:tcPr>
                 </a:tc>
+                <a:extLst>
+                  <a:ext uri="{0D108BD9-81ED-4DB2-BD59-A6C34878D82A}">
+                    <a16:rowId xmlns:a16="http://schemas.microsoft.com/office/drawing/2014/main" val="10002"/>
+                  </a:ext>
+                </a:extLst>
               </a:tr>
               <a:tr h="280000">
                 <a:tc>
@@ -19328,7 +19396,7 @@
                       </a:r>
                     </a:p>
                   </a:txBody>
-                  <a:tcPr marL="91440" marR="91440" marT="36576" marB="36576" anchor="ctr">
+                  <a:tcPr marT="36576" marB="36576" anchor="ctr">
                     <a:lnL w="6350" cap="flat" cmpd="sng" algn="ctr">
                       <a:solidFill>
                         <a:srgbClr val="CCDFE8"/>
@@ -19379,7 +19447,7 @@
                       </a:r>
                     </a:p>
                   </a:txBody>
-                  <a:tcPr marL="91440" marR="91440" marT="36576" marB="36576" anchor="ctr">
+                  <a:tcPr marT="36576" marB="36576" anchor="ctr">
                     <a:lnL w="6350" cap="flat" cmpd="sng" algn="ctr">
                       <a:solidFill>
                         <a:srgbClr val="CCDFE8"/>
@@ -19430,7 +19498,7 @@
                       </a:r>
                     </a:p>
                   </a:txBody>
-                  <a:tcPr marL="91440" marR="91440" marT="36576" marB="36576" anchor="ctr">
+                  <a:tcPr marT="36576" marB="36576" anchor="ctr">
                     <a:lnL w="6350" cap="flat" cmpd="sng" algn="ctr">
                       <a:solidFill>
                         <a:srgbClr val="CCDFE8"/>
@@ -19481,7 +19549,7 @@
                       </a:r>
                     </a:p>
                   </a:txBody>
-                  <a:tcPr marL="91440" marR="91440" marT="36576" marB="36576" anchor="ctr">
+                  <a:tcPr marT="36576" marB="36576" anchor="ctr">
                     <a:lnL w="6350" cap="flat" cmpd="sng" algn="ctr">
                       <a:solidFill>
                         <a:srgbClr val="CCDFE8"/>
@@ -19511,6 +19579,11 @@
                     </a:solidFill>
                   </a:tcPr>
                 </a:tc>
+                <a:extLst>
+                  <a:ext uri="{0D108BD9-81ED-4DB2-BD59-A6C34878D82A}">
+                    <a16:rowId xmlns:a16="http://schemas.microsoft.com/office/drawing/2014/main" val="10003"/>
+                  </a:ext>
+                </a:extLst>
               </a:tr>
               <a:tr h="280000">
                 <a:tc>
@@ -19534,7 +19607,7 @@
                       </a:r>
                     </a:p>
                   </a:txBody>
-                  <a:tcPr marL="91440" marR="91440" marT="36576" marB="36576" anchor="ctr">
+                  <a:tcPr marT="36576" marB="36576" anchor="ctr">
                     <a:lnL w="6350" cap="flat" cmpd="sng" algn="ctr">
                       <a:solidFill>
                         <a:srgbClr val="CCDFE8"/>
@@ -19585,7 +19658,7 @@
                       </a:r>
                     </a:p>
                   </a:txBody>
-                  <a:tcPr marL="91440" marR="91440" marT="36576" marB="36576" anchor="ctr">
+                  <a:tcPr marT="36576" marB="36576" anchor="ctr">
                     <a:lnL w="6350" cap="flat" cmpd="sng" algn="ctr">
                       <a:solidFill>
                         <a:srgbClr val="CCDFE8"/>
@@ -19636,7 +19709,7 @@
                       </a:r>
                     </a:p>
                   </a:txBody>
-                  <a:tcPr marL="91440" marR="91440" marT="36576" marB="36576" anchor="ctr">
+                  <a:tcPr marT="36576" marB="36576" anchor="ctr">
                     <a:lnL w="6350" cap="flat" cmpd="sng" algn="ctr">
                       <a:solidFill>
                         <a:srgbClr val="CCDFE8"/>
@@ -19687,7 +19760,7 @@
                       </a:r>
                     </a:p>
                   </a:txBody>
-                  <a:tcPr marL="91440" marR="91440" marT="36576" marB="36576" anchor="ctr">
+                  <a:tcPr marT="36576" marB="36576" anchor="ctr">
                     <a:lnL w="6350" cap="flat" cmpd="sng" algn="ctr">
                       <a:solidFill>
                         <a:srgbClr val="CCDFE8"/>
@@ -19717,6 +19790,11 @@
                     </a:solidFill>
                   </a:tcPr>
                 </a:tc>
+                <a:extLst>
+                  <a:ext uri="{0D108BD9-81ED-4DB2-BD59-A6C34878D82A}">
+                    <a16:rowId xmlns:a16="http://schemas.microsoft.com/office/drawing/2014/main" val="10004"/>
+                  </a:ext>
+                </a:extLst>
               </a:tr>
             </a:tbl>
           </a:graphicData>

</xml_diff>